<commit_message>
Slide 6: airplane (✈) icon before "Art of Possible — Broader Vision"
Co-Authored-By: Claude Opus 4.8 <noreply@anthropic.com>
</commit_message>
<xml_diff>
--- a/AI-Leave-System.pptx
+++ b/AI-Leave-System.pptx
@@ -5,14 +5,14 @@
     <p:sldMasterId id="2147483648" r:id="rId1"/>
   </p:sldMasterIdLst>
   <p:sldIdLst>
-    <p:sldId id="256" r:id="rId2"/>
-    <p:sldId id="257" r:id="rId3"/>
-    <p:sldId id="258" r:id="rId4"/>
-    <p:sldId id="259" r:id="rId5"/>
-    <p:sldId id="260" r:id="rId6"/>
-    <p:sldId id="261" r:id="rId7"/>
+    <p:sldId id="256" r:id="rId7"/>
+    <p:sldId id="257" r:id="rId8"/>
+    <p:sldId id="258" r:id="rId9"/>
+    <p:sldId id="259" r:id="rId10"/>
+    <p:sldId id="260" r:id="rId11"/>
+    <p:sldId id="261" r:id="rId12"/>
   </p:sldIdLst>
-  <p:sldSz cx="12192000" cy="6858000"/>
+  <p:sldSz cx="12191695" cy="6858000" type="screen4x3"/>
   <p:notesSz cx="6858000" cy="9144000"/>
   <p:defaultTextStyle>
     <a:defPPr>
@@ -109,22 +109,6 @@
       </a:defRPr>
     </a:lvl9pPr>
   </p:defaultTextStyle>
-  <p:extLst>
-    <p:ext uri="{EFAFB233-063F-42B5-8137-9DF3F51BA10A}">
-      <p15:sldGuideLst xmlns:p15="http://schemas.microsoft.com/office/powerpoint/2012/main">
-        <p15:guide id="1" orient="horz" pos="2160">
-          <p15:clr>
-            <a:srgbClr val="A4A3A4"/>
-          </p15:clr>
-        </p15:guide>
-        <p15:guide id="2" pos="2880">
-          <p15:clr>
-            <a:srgbClr val="A4A3A4"/>
-          </p15:clr>
-        </p15:guide>
-      </p15:sldGuideLst>
-    </p:ext>
-  </p:extLst>
 </p:presentation>
 </file>
 
@@ -309,7 +293,7 @@
           <a:p>
             <a:fld id="{5BCAD085-E8A6-8845-BD4E-CB4CCA059FC4}" type="datetimeFigureOut">
               <a:rPr lang="en-US" smtClean="0"/>
-              <a:t>6/18/2026</a:t>
+              <a:t>1/27/13</a:t>
             </a:fld>
             <a:endParaRPr lang="en-US"/>
           </a:p>
@@ -479,7 +463,7 @@
           <a:p>
             <a:fld id="{5BCAD085-E8A6-8845-BD4E-CB4CCA059FC4}" type="datetimeFigureOut">
               <a:rPr lang="en-US" smtClean="0"/>
-              <a:t>6/18/2026</a:t>
+              <a:t>1/27/13</a:t>
             </a:fld>
             <a:endParaRPr lang="en-US"/>
           </a:p>
@@ -659,7 +643,7 @@
           <a:p>
             <a:fld id="{5BCAD085-E8A6-8845-BD4E-CB4CCA059FC4}" type="datetimeFigureOut">
               <a:rPr lang="en-US" smtClean="0"/>
-              <a:t>6/18/2026</a:t>
+              <a:t>1/27/13</a:t>
             </a:fld>
             <a:endParaRPr lang="en-US"/>
           </a:p>
@@ -829,7 +813,7 @@
           <a:p>
             <a:fld id="{5BCAD085-E8A6-8845-BD4E-CB4CCA059FC4}" type="datetimeFigureOut">
               <a:rPr lang="en-US" smtClean="0"/>
-              <a:t>6/18/2026</a:t>
+              <a:t>1/27/13</a:t>
             </a:fld>
             <a:endParaRPr lang="en-US"/>
           </a:p>
@@ -1075,7 +1059,7 @@
           <a:p>
             <a:fld id="{5BCAD085-E8A6-8845-BD4E-CB4CCA059FC4}" type="datetimeFigureOut">
               <a:rPr lang="en-US" smtClean="0"/>
-              <a:t>6/18/2026</a:t>
+              <a:t>1/27/13</a:t>
             </a:fld>
             <a:endParaRPr lang="en-US"/>
           </a:p>
@@ -1363,7 +1347,7 @@
           <a:p>
             <a:fld id="{5BCAD085-E8A6-8845-BD4E-CB4CCA059FC4}" type="datetimeFigureOut">
               <a:rPr lang="en-US" smtClean="0"/>
-              <a:t>6/18/2026</a:t>
+              <a:t>1/27/13</a:t>
             </a:fld>
             <a:endParaRPr lang="en-US"/>
           </a:p>
@@ -1785,7 +1769,7 @@
           <a:p>
             <a:fld id="{5BCAD085-E8A6-8845-BD4E-CB4CCA059FC4}" type="datetimeFigureOut">
               <a:rPr lang="en-US" smtClean="0"/>
-              <a:t>6/18/2026</a:t>
+              <a:t>1/27/13</a:t>
             </a:fld>
             <a:endParaRPr lang="en-US"/>
           </a:p>
@@ -1903,7 +1887,7 @@
           <a:p>
             <a:fld id="{5BCAD085-E8A6-8845-BD4E-CB4CCA059FC4}" type="datetimeFigureOut">
               <a:rPr lang="en-US" smtClean="0"/>
-              <a:t>6/18/2026</a:t>
+              <a:t>1/27/13</a:t>
             </a:fld>
             <a:endParaRPr lang="en-US"/>
           </a:p>
@@ -1998,7 +1982,7 @@
           <a:p>
             <a:fld id="{5BCAD085-E8A6-8845-BD4E-CB4CCA059FC4}" type="datetimeFigureOut">
               <a:rPr lang="en-US" smtClean="0"/>
-              <a:t>6/18/2026</a:t>
+              <a:t>1/27/13</a:t>
             </a:fld>
             <a:endParaRPr lang="en-US"/>
           </a:p>
@@ -2275,7 +2259,7 @@
           <a:p>
             <a:fld id="{5BCAD085-E8A6-8845-BD4E-CB4CCA059FC4}" type="datetimeFigureOut">
               <a:rPr lang="en-US" smtClean="0"/>
-              <a:t>6/18/2026</a:t>
+              <a:t>1/27/13</a:t>
             </a:fld>
             <a:endParaRPr lang="en-US"/>
           </a:p>
@@ -2528,7 +2512,7 @@
           <a:p>
             <a:fld id="{5BCAD085-E8A6-8845-BD4E-CB4CCA059FC4}" type="datetimeFigureOut">
               <a:rPr lang="en-US" smtClean="0"/>
-              <a:t>6/18/2026</a:t>
+              <a:t>1/27/13</a:t>
             </a:fld>
             <a:endParaRPr lang="en-US"/>
           </a:p>
@@ -2741,7 +2725,7 @@
           <a:p>
             <a:fld id="{5BCAD085-E8A6-8845-BD4E-CB4CCA059FC4}" type="datetimeFigureOut">
               <a:rPr lang="en-US" smtClean="0"/>
-              <a:t>6/18/2026</a:t>
+              <a:t>1/27/13</a:t>
             </a:fld>
             <a:endParaRPr lang="en-US"/>
           </a:p>
@@ -3100,7 +3084,7 @@
 </file>
 
 <file path=ppt/slides/slide1.xml><?xml version="1.0" encoding="utf-8"?>
-<p:sld xmlns:a="http://schemas.openxmlformats.org/drawingml/2006/main" xmlns:r="http://schemas.openxmlformats.org/officeDocument/2006/relationships" xmlns:p="http://schemas.openxmlformats.org/presentationml/2006/main">
+<p:sld xmlns:a="http://schemas.openxmlformats.org/drawingml/2006/main" xmlns:p="http://schemas.openxmlformats.org/presentationml/2006/main" xmlns:r="http://schemas.openxmlformats.org/officeDocument/2006/relationships">
   <p:cSld>
     <p:bg>
       <p:bgPr>
@@ -3116,14 +3100,7 @@
         <p:cNvGrpSpPr/>
         <p:nvPr/>
       </p:nvGrpSpPr>
-      <p:grpSpPr>
-        <a:xfrm>
-          <a:off x="0" y="0"/>
-          <a:ext cx="0" cy="0"/>
-          <a:chOff x="0" y="0"/>
-          <a:chExt cx="0" cy="0"/>
-        </a:xfrm>
-      </p:grpSpPr>
+      <p:grpSpPr/>
       <p:sp>
         <p:nvSpPr>
           <p:cNvPr id="2" name="Rounded Rectangle 1"/>
@@ -3167,7 +3144,6 @@
           <a:lstStyle/>
           <a:p>
             <a:pPr algn="ctr"/>
-            <a:endParaRPr/>
           </a:p>
         </p:txBody>
       </p:sp>
@@ -3214,7 +3190,6 @@
           <a:lstStyle/>
           <a:p>
             <a:pPr algn="ctr"/>
-            <a:endParaRPr/>
           </a:p>
         </p:txBody>
       </p:sp>
@@ -3259,7 +3234,6 @@
           <a:lstStyle/>
           <a:p>
             <a:pPr algn="ctr"/>
-            <a:endParaRPr/>
           </a:p>
         </p:txBody>
       </p:sp>
@@ -3280,7 +3254,7 @@
           <a:noFill/>
         </p:spPr>
         <p:txBody>
-          <a:bodyPr wrap="square" lIns="0" tIns="0" rIns="0" bIns="0" anchor="ctr">
+          <a:bodyPr wrap="square" anchor="ctr" lIns="0" rIns="0" tIns="0" bIns="0">
             <a:spAutoFit/>
           </a:bodyPr>
           <a:lstStyle/>
@@ -3348,7 +3322,6 @@
           <a:lstStyle/>
           <a:p>
             <a:pPr algn="ctr"/>
-            <a:endParaRPr/>
           </a:p>
         </p:txBody>
       </p:sp>
@@ -3369,7 +3342,7 @@
           <a:noFill/>
         </p:spPr>
         <p:txBody>
-          <a:bodyPr wrap="none" lIns="0" tIns="0" rIns="0" bIns="0" anchor="ctr">
+          <a:bodyPr wrap="none" anchor="ctr" lIns="0" rIns="0" tIns="0" bIns="0">
             <a:spAutoFit/>
           </a:bodyPr>
           <a:lstStyle/>
@@ -3437,7 +3410,6 @@
           <a:lstStyle/>
           <a:p>
             <a:pPr algn="ctr"/>
-            <a:endParaRPr/>
           </a:p>
         </p:txBody>
       </p:sp>
@@ -3532,7 +3504,6 @@
           <a:lstStyle/>
           <a:p>
             <a:pPr algn="ctr"/>
-            <a:endParaRPr/>
           </a:p>
         </p:txBody>
       </p:sp>
@@ -3553,7 +3524,7 @@
           <a:noFill/>
         </p:spPr>
         <p:txBody>
-          <a:bodyPr wrap="square" lIns="0" tIns="0" rIns="0" bIns="0" anchor="ctr">
+          <a:bodyPr wrap="square" anchor="ctr" lIns="0" rIns="0" tIns="0" bIns="0">
             <a:spAutoFit/>
           </a:bodyPr>
           <a:lstStyle/>
@@ -3595,7 +3566,7 @@
           <a:noFill/>
         </p:spPr>
         <p:txBody>
-          <a:bodyPr wrap="square" lIns="0" tIns="0" rIns="0" bIns="0" anchor="t">
+          <a:bodyPr wrap="square" anchor="t" lIns="0" rIns="0" tIns="0" bIns="0">
             <a:spAutoFit/>
           </a:bodyPr>
           <a:lstStyle/>
@@ -3637,7 +3608,7 @@
           <a:noFill/>
         </p:spPr>
         <p:txBody>
-          <a:bodyPr wrap="square" lIns="0" tIns="0" rIns="0" bIns="0" anchor="t">
+          <a:bodyPr wrap="square" anchor="t" lIns="0" rIns="0" tIns="0" bIns="0">
             <a:spAutoFit/>
           </a:bodyPr>
           <a:lstStyle/>
@@ -3705,7 +3676,6 @@
           <a:lstStyle/>
           <a:p>
             <a:pPr algn="ctr"/>
-            <a:endParaRPr/>
           </a:p>
         </p:txBody>
       </p:sp>
@@ -3726,7 +3696,7 @@
           <a:noFill/>
         </p:spPr>
         <p:txBody>
-          <a:bodyPr wrap="square" lIns="0" tIns="0" rIns="0" bIns="0" anchor="t">
+          <a:bodyPr wrap="square" anchor="t" lIns="0" rIns="0" tIns="0" bIns="0">
             <a:spAutoFit/>
           </a:bodyPr>
           <a:lstStyle/>
@@ -3809,7 +3779,7 @@
           </a:fontRef>
         </p:style>
         <p:txBody>
-          <a:bodyPr wrap="none" lIns="0" tIns="0" rIns="0" bIns="0" rtlCol="0" anchor="ctr"/>
+          <a:bodyPr rtlCol="0" anchor="ctr" wrap="none" lIns="0" rIns="0" tIns="0" bIns="0"/>
           <a:lstStyle/>
           <a:p>
             <a:pPr algn="ctr">
@@ -3832,6 +3802,30 @@
           </a:p>
         </p:txBody>
       </p:sp>
+      <p:pic>
+        <p:nvPicPr>
+          <p:cNvPr id="18" name="Picture 17" descr="cognizant logo.png"/>
+          <p:cNvPicPr>
+            <a:picLocks noChangeAspect="1"/>
+          </p:cNvPicPr>
+          <p:nvPr/>
+        </p:nvPicPr>
+        <p:blipFill>
+          <a:blip r:embed="rId2"/>
+          <a:stretch>
+            <a:fillRect/>
+          </a:stretch>
+        </p:blipFill>
+        <p:spPr>
+          <a:xfrm>
+            <a:off x="594360" y="6108192"/>
+            <a:ext cx="658397" cy="202082"/>
+          </a:xfrm>
+          <a:prstGeom prst="rect">
+            <a:avLst/>
+          </a:prstGeom>
+        </p:spPr>
+      </p:pic>
       <p:sp>
         <p:nvSpPr>
           <p:cNvPr id="19" name="TextBox 18"/>
@@ -3849,7 +3843,7 @@
           <a:noFill/>
         </p:spPr>
         <p:txBody>
-          <a:bodyPr wrap="square" lIns="0" tIns="0" rIns="0" bIns="0" anchor="ctr">
+          <a:bodyPr wrap="square" anchor="ctr" lIns="0" rIns="0" tIns="0" bIns="0">
             <a:spAutoFit/>
           </a:bodyPr>
           <a:lstStyle/>
@@ -3891,7 +3885,7 @@
           <a:noFill/>
         </p:spPr>
         <p:txBody>
-          <a:bodyPr wrap="square" lIns="0" tIns="0" rIns="0" bIns="0" anchor="ctr">
+          <a:bodyPr wrap="square" anchor="ctr" lIns="0" rIns="0" tIns="0" bIns="0">
             <a:spAutoFit/>
           </a:bodyPr>
           <a:lstStyle/>
@@ -3925,7 +3919,7 @@
 </file>
 
 <file path=ppt/slides/slide2.xml><?xml version="1.0" encoding="utf-8"?>
-<p:sld xmlns:a="http://schemas.openxmlformats.org/drawingml/2006/main" xmlns:r="http://schemas.openxmlformats.org/officeDocument/2006/relationships" xmlns:p="http://schemas.openxmlformats.org/presentationml/2006/main">
+<p:sld xmlns:a="http://schemas.openxmlformats.org/drawingml/2006/main" xmlns:p="http://schemas.openxmlformats.org/presentationml/2006/main" xmlns:r="http://schemas.openxmlformats.org/officeDocument/2006/relationships">
   <p:cSld>
     <p:bg>
       <p:bgPr>
@@ -3941,14 +3935,7 @@
         <p:cNvGrpSpPr/>
         <p:nvPr/>
       </p:nvGrpSpPr>
-      <p:grpSpPr>
-        <a:xfrm>
-          <a:off x="0" y="0"/>
-          <a:ext cx="0" cy="0"/>
-          <a:chOff x="0" y="0"/>
-          <a:chExt cx="0" cy="0"/>
-        </a:xfrm>
-      </p:grpSpPr>
+      <p:grpSpPr/>
       <p:sp>
         <p:nvSpPr>
           <p:cNvPr id="2" name="Rounded Rectangle 1"/>
@@ -3992,7 +3979,6 @@
           <a:lstStyle/>
           <a:p>
             <a:pPr algn="ctr"/>
-            <a:endParaRPr/>
           </a:p>
         </p:txBody>
       </p:sp>
@@ -4004,7 +3990,7 @@
         </p:nvSpPr>
         <p:spPr>
           <a:xfrm>
-            <a:off x="365760" y="340593"/>
+            <a:off x="365760" y="365760"/>
             <a:ext cx="6400800" cy="6126480"/>
           </a:xfrm>
           <a:prstGeom prst="roundRect">
@@ -4039,7 +4025,6 @@
           <a:lstStyle/>
           <a:p>
             <a:pPr algn="ctr"/>
-            <a:endParaRPr/>
           </a:p>
         </p:txBody>
       </p:sp>
@@ -4082,7 +4067,7 @@
           </a:fontRef>
         </p:style>
         <p:txBody>
-          <a:bodyPr wrap="none" lIns="0" tIns="0" rIns="0" bIns="0" rtlCol="0" anchor="ctr"/>
+          <a:bodyPr rtlCol="0" anchor="ctr" wrap="none" lIns="0" rIns="0" tIns="0" bIns="0"/>
           <a:lstStyle/>
           <a:p>
             <a:pPr algn="ctr">
@@ -4114,7 +4099,7 @@
         <p:spPr>
           <a:xfrm>
             <a:off x="868680" y="1234440"/>
-            <a:ext cx="5897880" cy="446276"/>
+            <a:ext cx="10360152" cy="822960"/>
           </a:xfrm>
           <a:prstGeom prst="rect">
             <a:avLst/>
@@ -4122,7 +4107,7 @@
           <a:noFill/>
         </p:spPr>
         <p:txBody>
-          <a:bodyPr wrap="square" lIns="0" tIns="0" rIns="0" bIns="0" anchor="t">
+          <a:bodyPr wrap="square" anchor="t" lIns="0" rIns="0" tIns="0" bIns="0">
             <a:spAutoFit/>
           </a:bodyPr>
           <a:lstStyle/>
@@ -4136,7 +4121,7 @@
               </a:spcAft>
             </a:pPr>
             <a:r>
-              <a:rPr sz="2900" b="1" i="0" dirty="0">
+              <a:rPr sz="2900" b="1" i="0">
                 <a:solidFill>
                   <a:srgbClr val="1B2A4A"/>
                 </a:solidFill>
@@ -4192,7 +4177,6 @@
           <a:lstStyle/>
           <a:p>
             <a:pPr algn="ctr"/>
-            <a:endParaRPr/>
           </a:p>
         </p:txBody>
       </p:sp>
@@ -4213,7 +4197,7 @@
           <a:noFill/>
         </p:spPr>
         <p:txBody>
-          <a:bodyPr wrap="square" lIns="0" tIns="0" rIns="0" bIns="0" anchor="t">
+          <a:bodyPr wrap="square" anchor="t" lIns="0" rIns="0" tIns="0" bIns="0">
             <a:spAutoFit/>
           </a:bodyPr>
           <a:lstStyle/>
@@ -4302,7 +4286,6 @@
           <a:lstStyle/>
           <a:p>
             <a:pPr algn="ctr"/>
-            <a:endParaRPr/>
           </a:p>
         </p:txBody>
       </p:sp>
@@ -4323,7 +4306,7 @@
           <a:noFill/>
         </p:spPr>
         <p:txBody>
-          <a:bodyPr wrap="square" lIns="0" tIns="0" rIns="0" bIns="0" anchor="t">
+          <a:bodyPr wrap="square" anchor="t" lIns="0" rIns="0" tIns="0" bIns="0">
             <a:spAutoFit/>
           </a:bodyPr>
           <a:lstStyle/>
@@ -4412,7 +4395,6 @@
           <a:lstStyle/>
           <a:p>
             <a:pPr algn="ctr"/>
-            <a:endParaRPr/>
           </a:p>
         </p:txBody>
       </p:sp>
@@ -4433,7 +4415,7 @@
           <a:noFill/>
         </p:spPr>
         <p:txBody>
-          <a:bodyPr wrap="square" lIns="0" tIns="0" rIns="0" bIns="0" anchor="t">
+          <a:bodyPr wrap="square" anchor="t" lIns="0" rIns="0" tIns="0" bIns="0">
             <a:spAutoFit/>
           </a:bodyPr>
           <a:lstStyle/>
@@ -4522,7 +4504,6 @@
           <a:lstStyle/>
           <a:p>
             <a:pPr algn="ctr"/>
-            <a:endParaRPr/>
           </a:p>
         </p:txBody>
       </p:sp>
@@ -4543,7 +4524,7 @@
           <a:noFill/>
         </p:spPr>
         <p:txBody>
-          <a:bodyPr wrap="square" lIns="0" tIns="0" rIns="0" bIns="0" anchor="t">
+          <a:bodyPr wrap="square" anchor="t" lIns="0" rIns="0" tIns="0" bIns="0">
             <a:spAutoFit/>
           </a:bodyPr>
           <a:lstStyle/>
@@ -4624,7 +4605,7 @@
           </a:fontRef>
         </p:style>
         <p:txBody>
-          <a:bodyPr lIns="0" tIns="0" rIns="0" bIns="0" rtlCol="0" anchor="ctr"/>
+          <a:bodyPr rtlCol="0" anchor="ctr" lIns="0" rIns="0" tIns="0" bIns="0"/>
           <a:lstStyle/>
           <a:p>
             <a:pPr algn="ctr">
@@ -4664,7 +4645,7 @@
           <a:noFill/>
         </p:spPr>
         <p:txBody>
-          <a:bodyPr wrap="square" lIns="0" tIns="0" rIns="0" bIns="0" anchor="t">
+          <a:bodyPr wrap="square" anchor="t" lIns="0" rIns="0" tIns="0" bIns="0">
             <a:spAutoFit/>
           </a:bodyPr>
           <a:lstStyle/>
@@ -4749,7 +4730,6 @@
           <a:lstStyle/>
           <a:p>
             <a:pPr algn="ctr"/>
-            <a:endParaRPr/>
           </a:p>
         </p:txBody>
       </p:sp>
@@ -4790,7 +4770,7 @@
           </a:fontRef>
         </p:style>
         <p:txBody>
-          <a:bodyPr lIns="0" tIns="0" rIns="0" bIns="0" rtlCol="0" anchor="ctr"/>
+          <a:bodyPr rtlCol="0" anchor="ctr" lIns="0" rIns="0" tIns="0" bIns="0"/>
           <a:lstStyle/>
           <a:p>
             <a:pPr algn="ctr">
@@ -4830,7 +4810,7 @@
           <a:noFill/>
         </p:spPr>
         <p:txBody>
-          <a:bodyPr wrap="square" lIns="0" tIns="0" rIns="0" bIns="0" anchor="t">
+          <a:bodyPr wrap="square" anchor="t" lIns="0" rIns="0" tIns="0" bIns="0">
             <a:spAutoFit/>
           </a:bodyPr>
           <a:lstStyle/>
@@ -4915,7 +4895,6 @@
           <a:lstStyle/>
           <a:p>
             <a:pPr algn="ctr"/>
-            <a:endParaRPr/>
           </a:p>
         </p:txBody>
       </p:sp>
@@ -4956,7 +4935,7 @@
           </a:fontRef>
         </p:style>
         <p:txBody>
-          <a:bodyPr lIns="0" tIns="0" rIns="0" bIns="0" rtlCol="0" anchor="ctr"/>
+          <a:bodyPr rtlCol="0" anchor="ctr" lIns="0" rIns="0" tIns="0" bIns="0"/>
           <a:lstStyle/>
           <a:p>
             <a:pPr algn="ctr">
@@ -4996,7 +4975,7 @@
           <a:noFill/>
         </p:spPr>
         <p:txBody>
-          <a:bodyPr wrap="square" lIns="0" tIns="0" rIns="0" bIns="0" anchor="t">
+          <a:bodyPr wrap="square" anchor="t" lIns="0" rIns="0" tIns="0" bIns="0">
             <a:spAutoFit/>
           </a:bodyPr>
           <a:lstStyle/>
@@ -5085,7 +5064,6 @@
           <a:lstStyle/>
           <a:p>
             <a:pPr algn="ctr"/>
-            <a:endParaRPr/>
           </a:p>
         </p:txBody>
       </p:sp>
@@ -5106,7 +5084,7 @@
           <a:noFill/>
         </p:spPr>
         <p:txBody>
-          <a:bodyPr wrap="square" lIns="0" tIns="0" rIns="0" bIns="0" anchor="ctr">
+          <a:bodyPr wrap="square" anchor="ctr" lIns="0" rIns="0" tIns="0" bIns="0">
             <a:spAutoFit/>
           </a:bodyPr>
           <a:lstStyle/>
@@ -5172,7 +5150,7 @@
           <a:noFill/>
         </p:spPr>
         <p:txBody>
-          <a:bodyPr wrap="square" lIns="0" tIns="0" rIns="0" bIns="0" anchor="ctr">
+          <a:bodyPr wrap="square" anchor="ctr" lIns="0" rIns="0" tIns="0" bIns="0">
             <a:spAutoFit/>
           </a:bodyPr>
           <a:lstStyle/>
@@ -5214,7 +5192,7 @@
           <a:noFill/>
         </p:spPr>
         <p:txBody>
-          <a:bodyPr wrap="square" lIns="0" tIns="0" rIns="0" bIns="0" anchor="ctr">
+          <a:bodyPr wrap="square" anchor="ctr" lIns="0" rIns="0" tIns="0" bIns="0">
             <a:spAutoFit/>
           </a:bodyPr>
           <a:lstStyle/>
@@ -5248,7 +5226,7 @@
 </file>
 
 <file path=ppt/slides/slide3.xml><?xml version="1.0" encoding="utf-8"?>
-<p:sld xmlns:a="http://schemas.openxmlformats.org/drawingml/2006/main" xmlns:r="http://schemas.openxmlformats.org/officeDocument/2006/relationships" xmlns:p="http://schemas.openxmlformats.org/presentationml/2006/main">
+<p:sld xmlns:a="http://schemas.openxmlformats.org/drawingml/2006/main" xmlns:p="http://schemas.openxmlformats.org/presentationml/2006/main" xmlns:r="http://schemas.openxmlformats.org/officeDocument/2006/relationships">
   <p:cSld>
     <p:bg>
       <p:bgPr>
@@ -5264,14 +5242,7 @@
         <p:cNvGrpSpPr/>
         <p:nvPr/>
       </p:nvGrpSpPr>
-      <p:grpSpPr>
-        <a:xfrm>
-          <a:off x="0" y="0"/>
-          <a:ext cx="0" cy="0"/>
-          <a:chOff x="0" y="0"/>
-          <a:chExt cx="0" cy="0"/>
-        </a:xfrm>
-      </p:grpSpPr>
+      <p:grpSpPr/>
       <p:sp>
         <p:nvSpPr>
           <p:cNvPr id="2" name="Rounded Rectangle 1"/>
@@ -5280,8 +5251,8 @@
         </p:nvSpPr>
         <p:spPr>
           <a:xfrm>
-            <a:off x="365760" y="436227"/>
-            <a:ext cx="11457432" cy="5964572"/>
+            <a:off x="365760" y="365760"/>
+            <a:ext cx="11457432" cy="6126480"/>
           </a:xfrm>
           <a:prstGeom prst="roundRect">
             <a:avLst>
@@ -5315,7 +5286,6 @@
           <a:lstStyle/>
           <a:p>
             <a:pPr algn="ctr"/>
-            <a:endParaRPr/>
           </a:p>
         </p:txBody>
       </p:sp>
@@ -5358,7 +5328,7 @@
           </a:fontRef>
         </p:style>
         <p:txBody>
-          <a:bodyPr wrap="none" lIns="0" tIns="0" rIns="0" bIns="0" rtlCol="0" anchor="ctr"/>
+          <a:bodyPr rtlCol="0" anchor="ctr" wrap="none" lIns="0" rIns="0" tIns="0" bIns="0"/>
           <a:lstStyle/>
           <a:p>
             <a:pPr algn="ctr">
@@ -5398,7 +5368,7 @@
           <a:noFill/>
         </p:spPr>
         <p:txBody>
-          <a:bodyPr wrap="square" lIns="0" tIns="0" rIns="0" bIns="0" anchor="t">
+          <a:bodyPr wrap="square" anchor="t" lIns="0" rIns="0" tIns="0" bIns="0">
             <a:spAutoFit/>
           </a:bodyPr>
           <a:lstStyle/>
@@ -5431,7 +5401,7 @@
         </p:nvSpPr>
         <p:spPr>
           <a:xfrm>
-            <a:off x="868680" y="2039783"/>
+            <a:off x="868680" y="2148840"/>
             <a:ext cx="4937760" cy="1097280"/>
           </a:xfrm>
           <a:prstGeom prst="roundRect">
@@ -5468,7 +5438,6 @@
           <a:lstStyle/>
           <a:p>
             <a:pPr algn="ctr"/>
-            <a:endParaRPr/>
           </a:p>
         </p:txBody>
       </p:sp>
@@ -5480,8 +5449,8 @@
         </p:nvSpPr>
         <p:spPr>
           <a:xfrm>
-            <a:off x="1097280" y="2313433"/>
-            <a:ext cx="4204562" cy="789960"/>
+            <a:off x="1097280" y="2313432"/>
+            <a:ext cx="4480560" cy="804671"/>
           </a:xfrm>
           <a:prstGeom prst="rect">
             <a:avLst/>
@@ -5489,7 +5458,7 @@
           <a:noFill/>
         </p:spPr>
         <p:txBody>
-          <a:bodyPr wrap="square" lIns="0" tIns="0" rIns="0" bIns="0" anchor="t">
+          <a:bodyPr wrap="square" anchor="t" lIns="0" rIns="0" tIns="0" bIns="0">
             <a:spAutoFit/>
           </a:bodyPr>
           <a:lstStyle/>
@@ -5503,7 +5472,7 @@
               </a:spcAft>
             </a:pPr>
             <a:r>
-              <a:rPr sz="1350" b="1" i="0" dirty="0">
+              <a:rPr sz="1350" b="1" i="0">
                 <a:solidFill>
                   <a:srgbClr val="1B2A4A"/>
                 </a:solidFill>
@@ -5522,7 +5491,7 @@
               </a:spcAft>
             </a:pPr>
             <a:r>
-              <a:rPr sz="1150" b="0" i="1" dirty="0">
+              <a:rPr sz="1150" b="0" i="1">
                 <a:solidFill>
                   <a:srgbClr val="8A97B0"/>
                 </a:solidFill>
@@ -5541,7 +5510,7 @@
         </p:nvSpPr>
         <p:spPr>
           <a:xfrm>
-            <a:off x="868680" y="3184293"/>
+            <a:off x="868680" y="3310128"/>
             <a:ext cx="4937760" cy="1143000"/>
           </a:xfrm>
           <a:prstGeom prst="roundRect">
@@ -5578,7 +5547,6 @@
           <a:lstStyle/>
           <a:p>
             <a:pPr algn="ctr"/>
-            <a:endParaRPr/>
           </a:p>
         </p:txBody>
       </p:sp>
@@ -5599,7 +5567,7 @@
           <a:noFill/>
         </p:spPr>
         <p:txBody>
-          <a:bodyPr wrap="square" lIns="0" tIns="0" rIns="0" bIns="0" anchor="t">
+          <a:bodyPr wrap="square" anchor="t" lIns="0" rIns="0" tIns="0" bIns="0">
             <a:spAutoFit/>
           </a:bodyPr>
           <a:lstStyle/>
@@ -5613,7 +5581,7 @@
               </a:spcAft>
             </a:pPr>
             <a:r>
-              <a:rPr sz="1350" b="1" i="0" dirty="0">
+              <a:rPr sz="1350" b="1" i="0">
                 <a:solidFill>
                   <a:srgbClr val="1B2A4A"/>
                 </a:solidFill>
@@ -5632,31 +5600,13 @@
               </a:spcAft>
             </a:pPr>
             <a:r>
-              <a:rPr sz="1150" b="0" i="1" dirty="0">
+              <a:rPr sz="1150" b="0" i="1">
                 <a:solidFill>
                   <a:srgbClr val="8A97B0"/>
                 </a:solidFill>
                 <a:latin typeface="Calibri"/>
               </a:rPr>
-              <a:t>Input: a chat message → Processing: Claude drafts + deterministic rules validate (balance, doc policy, overlap) → Output: confirmation card, submission, </a:t>
-            </a:r>
-            <a:r>
-              <a:rPr sz="1150" b="0" i="1" dirty="0" err="1">
-                <a:solidFill>
-                  <a:srgbClr val="8A97B0"/>
-                </a:solidFill>
-                <a:latin typeface="Calibri"/>
-              </a:rPr>
-              <a:t>dept</a:t>
-            </a:r>
-            <a:r>
-              <a:rPr sz="1150" b="0" i="1" dirty="0">
-                <a:solidFill>
-                  <a:srgbClr val="8A97B0"/>
-                </a:solidFill>
-                <a:latin typeface="Calibri"/>
-              </a:rPr>
-              <a:t>-routed approval + email.</a:t>
+              <a:t>Input: a chat message → Processing: Claude drafts + deterministic rules validate (balance, doc policy, overlap) → Output: confirmation card, submission, dept-routed approval + email.</a:t>
             </a:r>
           </a:p>
         </p:txBody>
@@ -5669,7 +5619,7 @@
         </p:nvSpPr>
         <p:spPr>
           <a:xfrm>
-            <a:off x="868680" y="4404220"/>
+            <a:off x="868680" y="4572000"/>
             <a:ext cx="4937760" cy="274320"/>
           </a:xfrm>
           <a:prstGeom prst="rect">
@@ -5678,7 +5628,7 @@
           <a:noFill/>
         </p:spPr>
         <p:txBody>
-          <a:bodyPr wrap="square" lIns="0" tIns="0" rIns="0" bIns="0" anchor="t">
+          <a:bodyPr wrap="square" anchor="t" lIns="0" rIns="0" tIns="0" bIns="0">
             <a:spAutoFit/>
           </a:bodyPr>
           <a:lstStyle/>
@@ -5711,8 +5661,8 @@
         </p:nvSpPr>
         <p:spPr>
           <a:xfrm>
-            <a:off x="868680" y="4661762"/>
-            <a:ext cx="1270513" cy="301752"/>
+            <a:off x="868680" y="4846320"/>
+            <a:ext cx="1702612" cy="310896"/>
           </a:xfrm>
           <a:prstGeom prst="roundRect">
             <a:avLst>
@@ -5742,7 +5692,7 @@
           </a:fontRef>
         </p:style>
         <p:txBody>
-          <a:bodyPr wrap="none" lIns="0" tIns="0" rIns="0" bIns="0" rtlCol="0" anchor="ctr"/>
+          <a:bodyPr rtlCol="0" anchor="ctr" wrap="none" lIns="0" rIns="0" tIns="0" bIns="0"/>
           <a:lstStyle/>
           <a:p>
             <a:pPr algn="ctr">
@@ -5754,47 +5704,14 @@
               </a:spcAft>
             </a:pPr>
             <a:r>
-              <a:rPr lang="en-US" sz="950" b="1" dirty="0" smtClean="0">
+              <a:rPr sz="950" b="1" i="0">
                 <a:solidFill>
                   <a:srgbClr val="FFFFFF"/>
                 </a:solidFill>
                 <a:latin typeface="Calibri"/>
               </a:rPr>
-              <a:t>AI</a:t>
-            </a:r>
-            <a:r>
-              <a:rPr sz="950" b="1" i="0" dirty="0" smtClean="0">
-                <a:solidFill>
-                  <a:srgbClr val="FFFFFF"/>
-                </a:solidFill>
-                <a:latin typeface="Calibri"/>
-              </a:rPr>
-              <a:t> </a:t>
-            </a:r>
-            <a:r>
-              <a:rPr sz="950" b="1" i="0" dirty="0">
-                <a:solidFill>
-                  <a:srgbClr val="FFFFFF"/>
-                </a:solidFill>
-                <a:latin typeface="Calibri"/>
-              </a:rPr>
-              <a:t>/ </a:t>
-            </a:r>
-            <a:r>
-              <a:rPr sz="950" b="1" i="0" dirty="0" err="1">
-                <a:solidFill>
-                  <a:srgbClr val="FFFFFF"/>
-                </a:solidFill>
-                <a:latin typeface="Calibri"/>
-              </a:rPr>
-              <a:t>GenAI</a:t>
-            </a:r>
-            <a:endParaRPr sz="950" b="1" i="0" dirty="0">
-              <a:solidFill>
-                <a:srgbClr val="FFFFFF"/>
-              </a:solidFill>
-              <a:latin typeface="Calibri"/>
-            </a:endParaRPr>
+              <a:t>Claude / GenAI</a:t>
+            </a:r>
           </a:p>
         </p:txBody>
       </p:sp>
@@ -5806,8 +5723,8 @@
         </p:nvSpPr>
         <p:spPr>
           <a:xfrm>
-            <a:off x="2248922" y="4670906"/>
-            <a:ext cx="1299622" cy="292608"/>
+            <a:off x="2681020" y="4846320"/>
+            <a:ext cx="1900123" cy="310896"/>
           </a:xfrm>
           <a:prstGeom prst="roundRect">
             <a:avLst>
@@ -5837,7 +5754,7 @@
           </a:fontRef>
         </p:style>
         <p:txBody>
-          <a:bodyPr wrap="none" lIns="0" tIns="0" rIns="0" bIns="0" rtlCol="0" anchor="ctr"/>
+          <a:bodyPr rtlCol="0" anchor="ctr" wrap="none" lIns="0" rIns="0" tIns="0" bIns="0"/>
           <a:lstStyle/>
           <a:p>
             <a:pPr algn="ctr">
@@ -5849,29 +5766,14 @@
               </a:spcAft>
             </a:pPr>
             <a:r>
-              <a:rPr sz="950" b="1" i="0" dirty="0">
+              <a:rPr sz="950" b="1" i="0">
                 <a:solidFill>
                   <a:srgbClr val="FFFFFF"/>
                 </a:solidFill>
                 <a:latin typeface="Calibri"/>
               </a:rPr>
-              <a:t>Python · </a:t>
-            </a:r>
-            <a:r>
-              <a:rPr sz="950" b="1" i="0" dirty="0" err="1">
-                <a:solidFill>
-                  <a:srgbClr val="FFFFFF"/>
-                </a:solidFill>
-                <a:latin typeface="Calibri"/>
-              </a:rPr>
-              <a:t>FastAPI</a:t>
-            </a:r>
-            <a:endParaRPr sz="950" b="1" i="0" dirty="0">
-              <a:solidFill>
-                <a:srgbClr val="FFFFFF"/>
-              </a:solidFill>
-              <a:latin typeface="Calibri"/>
-            </a:endParaRPr>
+              <a:t>Python · FastAPI</a:t>
+            </a:r>
           </a:p>
         </p:txBody>
       </p:sp>
@@ -5883,7 +5785,7 @@
         </p:nvSpPr>
         <p:spPr>
           <a:xfrm>
-            <a:off x="3653798" y="4670906"/>
+            <a:off x="4690872" y="4846320"/>
             <a:ext cx="912571" cy="310896"/>
           </a:xfrm>
           <a:prstGeom prst="roundRect">
@@ -5914,7 +5816,7 @@
           </a:fontRef>
         </p:style>
         <p:txBody>
-          <a:bodyPr wrap="none" lIns="0" tIns="0" rIns="0" bIns="0" rtlCol="0" anchor="ctr"/>
+          <a:bodyPr rtlCol="0" anchor="ctr" wrap="none" lIns="0" rIns="0" tIns="0" bIns="0"/>
           <a:lstStyle/>
           <a:p>
             <a:pPr algn="ctr">
@@ -5926,7 +5828,7 @@
               </a:spcAft>
             </a:pPr>
             <a:r>
-              <a:rPr sz="950" b="1" i="0" dirty="0">
+              <a:rPr sz="950" b="1" i="0">
                 <a:solidFill>
                   <a:srgbClr val="FFFFFF"/>
                 </a:solidFill>
@@ -5945,8 +5847,8 @@
         </p:nvSpPr>
         <p:spPr>
           <a:xfrm>
-            <a:off x="4680589" y="4679085"/>
-            <a:ext cx="1125852" cy="327884"/>
+            <a:off x="5713171" y="4846320"/>
+            <a:ext cx="1603857" cy="310896"/>
           </a:xfrm>
           <a:prstGeom prst="roundRect">
             <a:avLst>
@@ -5976,7 +5878,7 @@
           </a:fontRef>
         </p:style>
         <p:txBody>
-          <a:bodyPr wrap="none" lIns="0" tIns="0" rIns="0" bIns="0" rtlCol="0" anchor="ctr"/>
+          <a:bodyPr rtlCol="0" anchor="ctr" wrap="none" lIns="0" rIns="0" tIns="0" bIns="0"/>
           <a:lstStyle/>
           <a:p>
             <a:pPr algn="ctr">
@@ -6038,7 +5940,7 @@
           </a:fontRef>
         </p:style>
         <p:txBody>
-          <a:bodyPr wrap="none" lIns="0" tIns="0" rIns="0" bIns="0" rtlCol="0" anchor="ctr"/>
+          <a:bodyPr rtlCol="0" anchor="ctr" wrap="none" lIns="0" rIns="0" tIns="0" bIns="0"/>
           <a:lstStyle/>
           <a:p>
             <a:pPr algn="ctr">
@@ -6069,7 +5971,7 @@
         </p:nvSpPr>
         <p:spPr>
           <a:xfrm>
-            <a:off x="868680" y="5167786"/>
+            <a:off x="868680" y="5285232"/>
             <a:ext cx="4937760" cy="658368"/>
           </a:xfrm>
           <a:prstGeom prst="roundRect">
@@ -6106,7 +6008,6 @@
           <a:lstStyle/>
           <a:p>
             <a:pPr algn="ctr"/>
-            <a:endParaRPr/>
           </a:p>
         </p:txBody>
       </p:sp>
@@ -6118,7 +6019,7 @@
         </p:nvSpPr>
         <p:spPr>
           <a:xfrm>
-            <a:off x="1097280" y="5192953"/>
+            <a:off x="1097280" y="5449824"/>
             <a:ext cx="4480560" cy="365759"/>
           </a:xfrm>
           <a:prstGeom prst="rect">
@@ -6127,7 +6028,7 @@
           <a:noFill/>
         </p:spPr>
         <p:txBody>
-          <a:bodyPr wrap="square" lIns="0" tIns="0" rIns="0" bIns="0" anchor="t">
+          <a:bodyPr wrap="square" anchor="t" lIns="0" rIns="0" tIns="0" bIns="0">
             <a:spAutoFit/>
           </a:bodyPr>
           <a:lstStyle/>
@@ -6141,7 +6042,7 @@
               </a:spcAft>
             </a:pPr>
             <a:r>
-              <a:rPr sz="1350" b="1" i="0" dirty="0">
+              <a:rPr sz="1350" b="1" i="0">
                 <a:solidFill>
                   <a:srgbClr val="1B2A4A"/>
                 </a:solidFill>
@@ -6160,49 +6061,13 @@
               </a:spcAft>
             </a:pPr>
             <a:r>
-              <a:rPr sz="1150" b="0" i="1" dirty="0">
+              <a:rPr sz="1150" b="0" i="1">
                 <a:solidFill>
                   <a:srgbClr val="8A97B0"/>
                 </a:solidFill>
                 <a:latin typeface="Calibri"/>
               </a:rPr>
-              <a:t>Deterministic guardrails, confirmation gate, role-based </a:t>
-            </a:r>
-            <a:r>
-              <a:rPr sz="1150" b="0" i="1" dirty="0" err="1">
-                <a:solidFill>
-                  <a:srgbClr val="8A97B0"/>
-                </a:solidFill>
-                <a:latin typeface="Calibri"/>
-              </a:rPr>
-              <a:t>auth</a:t>
-            </a:r>
-            <a:r>
-              <a:rPr sz="1150" b="0" i="1" dirty="0">
-                <a:solidFill>
-                  <a:srgbClr val="8A97B0"/>
-                </a:solidFill>
-                <a:latin typeface="Calibri"/>
-              </a:rPr>
-              <a:t>, </a:t>
-            </a:r>
-            <a:r>
-              <a:rPr sz="1150" b="0" i="1" dirty="0" err="1">
-                <a:solidFill>
-                  <a:srgbClr val="8A97B0"/>
-                </a:solidFill>
-                <a:latin typeface="Calibri"/>
-              </a:rPr>
-              <a:t>dept</a:t>
-            </a:r>
-            <a:r>
-              <a:rPr sz="1150" b="0" i="1" dirty="0">
-                <a:solidFill>
-                  <a:srgbClr val="8A97B0"/>
-                </a:solidFill>
-                <a:latin typeface="Calibri"/>
-              </a:rPr>
-              <a:t> routing, auto-approval SLA, audit log.</a:t>
+              <a:t>Deterministic guardrails, confirmation gate, role-based auth, dept routing, auto-approval SLA, audit log.</a:t>
             </a:r>
           </a:p>
         </p:txBody>
@@ -6224,7 +6089,7 @@
           <a:noFill/>
         </p:spPr>
         <p:txBody>
-          <a:bodyPr wrap="square" lIns="0" tIns="0" rIns="0" bIns="0" anchor="t">
+          <a:bodyPr wrap="square" anchor="t" lIns="0" rIns="0" tIns="0" bIns="0">
             <a:spAutoFit/>
           </a:bodyPr>
           <a:lstStyle/>
@@ -6292,7 +6157,6 @@
           <a:lstStyle/>
           <a:p>
             <a:pPr algn="ctr"/>
-            <a:endParaRPr/>
           </a:p>
         </p:txBody>
       </p:sp>
@@ -6313,7 +6177,7 @@
           <a:noFill/>
         </p:spPr>
         <p:txBody>
-          <a:bodyPr wrap="square" lIns="0" tIns="0" rIns="0" bIns="0" anchor="ctr">
+          <a:bodyPr wrap="square" anchor="ctr" lIns="0" rIns="0" tIns="0" bIns="0">
             <a:spAutoFit/>
           </a:bodyPr>
           <a:lstStyle/>
@@ -6374,7 +6238,7 @@
           <a:noFill/>
         </p:spPr>
         <p:txBody>
-          <a:bodyPr wrap="square" lIns="0" tIns="0" rIns="0" bIns="0" anchor="ctr">
+          <a:bodyPr wrap="square" anchor="ctr" lIns="0" rIns="0" tIns="0" bIns="0">
             <a:spAutoFit/>
           </a:bodyPr>
           <a:lstStyle/>
@@ -6442,7 +6306,6 @@
           <a:lstStyle/>
           <a:p>
             <a:pPr algn="ctr"/>
-            <a:endParaRPr/>
           </a:p>
         </p:txBody>
       </p:sp>
@@ -6454,8 +6317,8 @@
         </p:nvSpPr>
         <p:spPr>
           <a:xfrm>
-            <a:off x="8458200" y="2557419"/>
-            <a:ext cx="1234439" cy="389850"/>
+            <a:off x="8458200" y="2432304"/>
+            <a:ext cx="1234439" cy="640080"/>
           </a:xfrm>
           <a:prstGeom prst="rect">
             <a:avLst/>
@@ -6463,7 +6326,7 @@
           <a:noFill/>
         </p:spPr>
         <p:txBody>
-          <a:bodyPr wrap="square" lIns="0" tIns="0" rIns="0" bIns="0" anchor="ctr">
+          <a:bodyPr wrap="square" anchor="ctr" lIns="0" rIns="0" tIns="0" bIns="0">
             <a:spAutoFit/>
           </a:bodyPr>
           <a:lstStyle/>
@@ -6477,7 +6340,7 @@
               </a:spcAft>
             </a:pPr>
             <a:r>
-              <a:rPr sz="1250" b="1" i="0" dirty="0">
+              <a:rPr sz="1250" b="1" i="0">
                 <a:solidFill>
                   <a:srgbClr val="FFFFFF"/>
                 </a:solidFill>
@@ -6496,31 +6359,13 @@
               </a:spcAft>
             </a:pPr>
             <a:r>
-              <a:rPr lang="en-US" sz="950" b="0" i="0" dirty="0" smtClean="0">
+              <a:rPr sz="950" b="0" i="0">
                 <a:solidFill>
                   <a:srgbClr val="C9D6EC"/>
                 </a:solidFill>
                 <a:latin typeface="Calibri"/>
               </a:rPr>
-              <a:t>AI</a:t>
-            </a:r>
-            <a:r>
-              <a:rPr sz="950" b="0" i="0" dirty="0" smtClean="0">
-                <a:solidFill>
-                  <a:srgbClr val="C9D6EC"/>
-                </a:solidFill>
-                <a:latin typeface="Calibri"/>
-              </a:rPr>
-              <a:t> </a:t>
-            </a:r>
-            <a:r>
-              <a:rPr sz="950" b="0" i="0" dirty="0">
-                <a:solidFill>
-                  <a:srgbClr val="C9D6EC"/>
-                </a:solidFill>
-                <a:latin typeface="Calibri"/>
-              </a:rPr>
-              <a:t>+ Rules</a:t>
+              <a:t>Claude + Rules</a:t>
             </a:r>
           </a:p>
         </p:txBody>
@@ -6542,7 +6387,7 @@
           <a:noFill/>
         </p:spPr>
         <p:txBody>
-          <a:bodyPr wrap="square" lIns="0" tIns="0" rIns="0" bIns="0" anchor="ctr">
+          <a:bodyPr wrap="square" anchor="ctr" lIns="0" rIns="0" tIns="0" bIns="0">
             <a:spAutoFit/>
           </a:bodyPr>
           <a:lstStyle/>
@@ -6610,7 +6455,6 @@
           <a:lstStyle/>
           <a:p>
             <a:pPr algn="ctr"/>
-            <a:endParaRPr/>
           </a:p>
         </p:txBody>
       </p:sp>
@@ -6631,7 +6475,7 @@
           <a:noFill/>
         </p:spPr>
         <p:txBody>
-          <a:bodyPr wrap="square" lIns="0" tIns="0" rIns="0" bIns="0" anchor="ctr">
+          <a:bodyPr wrap="square" anchor="ctr" lIns="0" rIns="0" tIns="0" bIns="0">
             <a:spAutoFit/>
           </a:bodyPr>
           <a:lstStyle/>
@@ -6720,7 +6564,6 @@
           <a:lstStyle/>
           <a:p>
             <a:pPr algn="ctr"/>
-            <a:endParaRPr/>
           </a:p>
         </p:txBody>
       </p:sp>
@@ -6767,7 +6610,6 @@
           <a:lstStyle/>
           <a:p>
             <a:pPr algn="ctr"/>
-            <a:endParaRPr/>
           </a:p>
         </p:txBody>
       </p:sp>
@@ -6788,7 +6630,7 @@
           <a:noFill/>
         </p:spPr>
         <p:txBody>
-          <a:bodyPr wrap="square" lIns="0" tIns="0" rIns="0" bIns="0" anchor="ctr">
+          <a:bodyPr wrap="square" anchor="ctr" lIns="0" rIns="0" tIns="0" bIns="0">
             <a:spAutoFit/>
           </a:bodyPr>
           <a:lstStyle/>
@@ -6830,7 +6672,7 @@
           <a:noFill/>
         </p:spPr>
         <p:txBody>
-          <a:bodyPr wrap="square" lIns="0" tIns="0" rIns="0" bIns="0" anchor="ctr">
+          <a:bodyPr wrap="square" anchor="ctr" lIns="0" rIns="0" tIns="0" bIns="0">
             <a:spAutoFit/>
           </a:bodyPr>
           <a:lstStyle/>
@@ -6898,7 +6740,6 @@
           <a:lstStyle/>
           <a:p>
             <a:pPr algn="ctr"/>
-            <a:endParaRPr/>
           </a:p>
         </p:txBody>
       </p:sp>
@@ -6919,7 +6760,7 @@
           <a:noFill/>
         </p:spPr>
         <p:txBody>
-          <a:bodyPr wrap="square" lIns="0" tIns="0" rIns="0" bIns="0" anchor="ctr">
+          <a:bodyPr wrap="square" anchor="ctr" lIns="0" rIns="0" tIns="0" bIns="0">
             <a:spAutoFit/>
           </a:bodyPr>
           <a:lstStyle/>
@@ -6961,7 +6802,7 @@
           <a:noFill/>
         </p:spPr>
         <p:txBody>
-          <a:bodyPr wrap="square" lIns="0" tIns="0" rIns="0" bIns="0" anchor="ctr">
+          <a:bodyPr wrap="square" anchor="ctr" lIns="0" rIns="0" tIns="0" bIns="0">
             <a:spAutoFit/>
           </a:bodyPr>
           <a:lstStyle/>
@@ -7029,7 +6870,6 @@
           <a:lstStyle/>
           <a:p>
             <a:pPr algn="ctr"/>
-            <a:endParaRPr/>
           </a:p>
         </p:txBody>
       </p:sp>
@@ -7041,8 +6881,8 @@
         </p:nvSpPr>
         <p:spPr>
           <a:xfrm>
-            <a:off x="6949440" y="4450785"/>
-            <a:ext cx="4023360" cy="169277"/>
+            <a:off x="6949440" y="4370832"/>
+            <a:ext cx="4023360" cy="329184"/>
           </a:xfrm>
           <a:prstGeom prst="rect">
             <a:avLst/>
@@ -7050,7 +6890,7 @@
           <a:noFill/>
         </p:spPr>
         <p:txBody>
-          <a:bodyPr wrap="square" lIns="0" tIns="0" rIns="0" bIns="0" anchor="ctr">
+          <a:bodyPr wrap="square" anchor="ctr" lIns="0" rIns="0" tIns="0" bIns="0">
             <a:spAutoFit/>
           </a:bodyPr>
           <a:lstStyle/>
@@ -7064,31 +6904,13 @@
               </a:spcAft>
             </a:pPr>
             <a:r>
-              <a:rPr lang="en-US" sz="1100" b="1" i="0" dirty="0" smtClean="0">
+              <a:rPr sz="1100" b="1" i="0">
                 <a:solidFill>
                   <a:srgbClr val="1B2A4A"/>
                 </a:solidFill>
                 <a:latin typeface="Calibri"/>
               </a:rPr>
-              <a:t>AI</a:t>
-            </a:r>
-            <a:r>
-              <a:rPr sz="1100" b="1" i="0" dirty="0" smtClean="0">
-                <a:solidFill>
-                  <a:srgbClr val="1B2A4A"/>
-                </a:solidFill>
-                <a:latin typeface="Calibri"/>
-              </a:rPr>
-              <a:t>  </a:t>
-            </a:r>
-            <a:r>
-              <a:rPr sz="1100" b="1" i="0" dirty="0">
-                <a:solidFill>
-                  <a:srgbClr val="1B2A4A"/>
-                </a:solidFill>
-                <a:latin typeface="Calibri"/>
-              </a:rPr>
-              <a:t>+  Rules engine</a:t>
+              <a:t>Claude  +  Rules engine</a:t>
             </a:r>
           </a:p>
         </p:txBody>
@@ -7110,7 +6932,7 @@
           <a:noFill/>
         </p:spPr>
         <p:txBody>
-          <a:bodyPr wrap="square" lIns="0" tIns="0" rIns="0" bIns="0" anchor="ctr">
+          <a:bodyPr wrap="square" anchor="ctr" lIns="0" rIns="0" tIns="0" bIns="0">
             <a:spAutoFit/>
           </a:bodyPr>
           <a:lstStyle/>
@@ -7178,7 +7000,6 @@
           <a:lstStyle/>
           <a:p>
             <a:pPr algn="ctr"/>
-            <a:endParaRPr/>
           </a:p>
         </p:txBody>
       </p:sp>
@@ -7199,7 +7020,7 @@
           <a:noFill/>
         </p:spPr>
         <p:txBody>
-          <a:bodyPr wrap="square" lIns="0" tIns="0" rIns="0" bIns="0" anchor="ctr">
+          <a:bodyPr wrap="square" anchor="ctr" lIns="0" rIns="0" tIns="0" bIns="0">
             <a:spAutoFit/>
           </a:bodyPr>
           <a:lstStyle/>
@@ -7241,7 +7062,7 @@
           <a:noFill/>
         </p:spPr>
         <p:txBody>
-          <a:bodyPr wrap="square" lIns="0" tIns="0" rIns="0" bIns="0" anchor="ctr">
+          <a:bodyPr wrap="square" anchor="ctr" lIns="0" rIns="0" tIns="0" bIns="0">
             <a:spAutoFit/>
           </a:bodyPr>
           <a:lstStyle/>
@@ -7309,7 +7130,6 @@
           <a:lstStyle/>
           <a:p>
             <a:pPr algn="ctr"/>
-            <a:endParaRPr/>
           </a:p>
         </p:txBody>
       </p:sp>
@@ -7330,7 +7150,7 @@
           <a:noFill/>
         </p:spPr>
         <p:txBody>
-          <a:bodyPr wrap="square" lIns="0" tIns="0" rIns="0" bIns="0" anchor="ctr">
+          <a:bodyPr wrap="square" anchor="ctr" lIns="0" rIns="0" tIns="0" bIns="0">
             <a:spAutoFit/>
           </a:bodyPr>
           <a:lstStyle/>
@@ -7372,7 +7192,7 @@
           <a:noFill/>
         </p:spPr>
         <p:txBody>
-          <a:bodyPr wrap="square" lIns="0" tIns="0" rIns="0" bIns="0" anchor="ctr">
+          <a:bodyPr wrap="square" anchor="ctr" lIns="0" rIns="0" tIns="0" bIns="0">
             <a:spAutoFit/>
           </a:bodyPr>
           <a:lstStyle/>
@@ -7440,7 +7260,6 @@
           <a:lstStyle/>
           <a:p>
             <a:pPr algn="ctr"/>
-            <a:endParaRPr/>
           </a:p>
         </p:txBody>
       </p:sp>
@@ -7461,7 +7280,7 @@
           <a:noFill/>
         </p:spPr>
         <p:txBody>
-          <a:bodyPr wrap="square" lIns="0" tIns="0" rIns="0" bIns="0" anchor="ctr">
+          <a:bodyPr wrap="square" anchor="ctr" lIns="0" rIns="0" tIns="0" bIns="0">
             <a:spAutoFit/>
           </a:bodyPr>
           <a:lstStyle/>
@@ -7527,7 +7346,7 @@
           <a:noFill/>
         </p:spPr>
         <p:txBody>
-          <a:bodyPr wrap="square" lIns="0" tIns="0" rIns="0" bIns="0" anchor="ctr">
+          <a:bodyPr wrap="square" anchor="ctr" lIns="0" rIns="0" tIns="0" bIns="0">
             <a:spAutoFit/>
           </a:bodyPr>
           <a:lstStyle/>
@@ -7569,7 +7388,7 @@
           <a:noFill/>
         </p:spPr>
         <p:txBody>
-          <a:bodyPr wrap="square" lIns="0" tIns="0" rIns="0" bIns="0" anchor="ctr">
+          <a:bodyPr wrap="square" anchor="ctr" lIns="0" rIns="0" tIns="0" bIns="0">
             <a:spAutoFit/>
           </a:bodyPr>
           <a:lstStyle/>
@@ -7603,7 +7422,7 @@
 </file>
 
 <file path=ppt/slides/slide4.xml><?xml version="1.0" encoding="utf-8"?>
-<p:sld xmlns:a="http://schemas.openxmlformats.org/drawingml/2006/main" xmlns:r="http://schemas.openxmlformats.org/officeDocument/2006/relationships" xmlns:p="http://schemas.openxmlformats.org/presentationml/2006/main">
+<p:sld xmlns:a="http://schemas.openxmlformats.org/drawingml/2006/main" xmlns:p="http://schemas.openxmlformats.org/presentationml/2006/main" xmlns:r="http://schemas.openxmlformats.org/officeDocument/2006/relationships">
   <p:cSld>
     <p:bg>
       <p:bgPr>
@@ -7619,14 +7438,7 @@
         <p:cNvGrpSpPr/>
         <p:nvPr/>
       </p:nvGrpSpPr>
-      <p:grpSpPr>
-        <a:xfrm>
-          <a:off x="0" y="0"/>
-          <a:ext cx="0" cy="0"/>
-          <a:chOff x="0" y="0"/>
-          <a:chExt cx="0" cy="0"/>
-        </a:xfrm>
-      </p:grpSpPr>
+      <p:grpSpPr/>
       <p:sp>
         <p:nvSpPr>
           <p:cNvPr id="2" name="Rounded Rectangle 1"/>
@@ -7635,7 +7447,7 @@
         </p:nvSpPr>
         <p:spPr>
           <a:xfrm>
-            <a:off x="365760" y="315426"/>
+            <a:off x="365760" y="365760"/>
             <a:ext cx="11457432" cy="6126480"/>
           </a:xfrm>
           <a:prstGeom prst="roundRect">
@@ -7670,7 +7482,6 @@
           <a:lstStyle/>
           <a:p>
             <a:pPr algn="ctr"/>
-            <a:endParaRPr/>
           </a:p>
         </p:txBody>
       </p:sp>
@@ -7713,7 +7524,7 @@
           </a:fontRef>
         </p:style>
         <p:txBody>
-          <a:bodyPr wrap="none" lIns="0" tIns="0" rIns="0" bIns="0" rtlCol="0" anchor="ctr"/>
+          <a:bodyPr rtlCol="0" anchor="ctr" wrap="none" lIns="0" rIns="0" tIns="0" bIns="0"/>
           <a:lstStyle/>
           <a:p>
             <a:pPr algn="ctr">
@@ -7753,7 +7564,7 @@
           <a:noFill/>
         </p:spPr>
         <p:txBody>
-          <a:bodyPr wrap="square" lIns="0" tIns="0" rIns="0" bIns="0" anchor="t">
+          <a:bodyPr wrap="square" anchor="t" lIns="0" rIns="0" tIns="0" bIns="0">
             <a:spAutoFit/>
           </a:bodyPr>
           <a:lstStyle/>
@@ -7823,7 +7634,6 @@
           <a:lstStyle/>
           <a:p>
             <a:pPr algn="ctr"/>
-            <a:endParaRPr/>
           </a:p>
         </p:txBody>
       </p:sp>
@@ -7892,7 +7702,6 @@
           <a:lstStyle/>
           <a:p>
             <a:pPr algn="ctr"/>
-            <a:endParaRPr/>
           </a:p>
         </p:txBody>
       </p:sp>
@@ -7904,8 +7713,8 @@
         </p:nvSpPr>
         <p:spPr>
           <a:xfrm>
-            <a:off x="1097280" y="5456625"/>
-            <a:ext cx="6035040" cy="169277"/>
+            <a:off x="1097280" y="5321808"/>
+            <a:ext cx="6035040" cy="438912"/>
           </a:xfrm>
           <a:prstGeom prst="rect">
             <a:avLst/>
@@ -7913,7 +7722,7 @@
           <a:noFill/>
         </p:spPr>
         <p:txBody>
-          <a:bodyPr wrap="square" lIns="0" tIns="0" rIns="0" bIns="0" anchor="ctr">
+          <a:bodyPr wrap="square" anchor="ctr" lIns="0" rIns="0" tIns="0" bIns="0">
             <a:spAutoFit/>
           </a:bodyPr>
           <a:lstStyle/>
@@ -7927,38 +7736,14 @@
               </a:spcAft>
             </a:pPr>
             <a:r>
-              <a:rPr sz="1100" b="1" i="0" dirty="0">
+              <a:rPr sz="1100" b="1" i="0">
                 <a:solidFill>
                   <a:srgbClr val="FFFFFF"/>
                 </a:solidFill>
                 <a:latin typeface="Calibri"/>
               </a:rPr>
-              <a:t>Status: [ Working prototype / MVP ]   Repo</a:t>
-            </a:r>
-            <a:r>
-              <a:rPr sz="1100" b="1" i="0" dirty="0" smtClean="0">
-                <a:solidFill>
-                  <a:srgbClr val="FFFFFF"/>
-                </a:solidFill>
-                <a:latin typeface="Calibri"/>
-              </a:rPr>
-              <a:t>:</a:t>
-            </a:r>
-            <a:r>
-              <a:rPr lang="en-US" sz="1100" b="1" i="0" dirty="0" smtClean="0">
-                <a:solidFill>
-                  <a:srgbClr val="FFFFFF"/>
-                </a:solidFill>
-                <a:latin typeface="Calibri"/>
-              </a:rPr>
-              <a:t> </a:t>
-            </a:r>
-            <a:endParaRPr sz="1100" b="1" i="0" dirty="0">
-              <a:solidFill>
-                <a:srgbClr val="FFFFFF"/>
-              </a:solidFill>
-              <a:latin typeface="Calibri"/>
-            </a:endParaRPr>
+              <a:t>Status: [ Working prototype / MVP ]   Repo: github.com/pbagsariya/AI-Leave-System</a:t>
+            </a:r>
           </a:p>
         </p:txBody>
       </p:sp>
@@ -8007,7 +7792,6 @@
           <a:lstStyle/>
           <a:p>
             <a:pPr algn="ctr"/>
-            <a:endParaRPr/>
           </a:p>
         </p:txBody>
       </p:sp>
@@ -8048,7 +7832,7 @@
           </a:fontRef>
         </p:style>
         <p:txBody>
-          <a:bodyPr lIns="0" tIns="0" rIns="0" bIns="0" rtlCol="0" anchor="ctr"/>
+          <a:bodyPr rtlCol="0" anchor="ctr" lIns="0" rIns="0" tIns="0" bIns="0"/>
           <a:lstStyle/>
           <a:p>
             <a:pPr algn="ctr">
@@ -8088,7 +7872,7 @@
           <a:noFill/>
         </p:spPr>
         <p:txBody>
-          <a:bodyPr wrap="square" lIns="0" tIns="0" rIns="0" bIns="0" anchor="t">
+          <a:bodyPr wrap="square" anchor="t" lIns="0" rIns="0" tIns="0" bIns="0">
             <a:spAutoFit/>
           </a:bodyPr>
           <a:lstStyle/>
@@ -8130,7 +7914,7 @@
           <a:noFill/>
         </p:spPr>
         <p:txBody>
-          <a:bodyPr wrap="square" lIns="0" tIns="0" rIns="0" bIns="0" anchor="t">
+          <a:bodyPr wrap="square" anchor="t" lIns="0" rIns="0" tIns="0" bIns="0">
             <a:spAutoFit/>
           </a:bodyPr>
           <a:lstStyle/>
@@ -8200,7 +7984,6 @@
           <a:lstStyle/>
           <a:p>
             <a:pPr algn="ctr"/>
-            <a:endParaRPr/>
           </a:p>
         </p:txBody>
       </p:sp>
@@ -8241,7 +8024,7 @@
           </a:fontRef>
         </p:style>
         <p:txBody>
-          <a:bodyPr lIns="0" tIns="0" rIns="0" bIns="0" rtlCol="0" anchor="ctr"/>
+          <a:bodyPr rtlCol="0" anchor="ctr" lIns="0" rIns="0" tIns="0" bIns="0"/>
           <a:lstStyle/>
           <a:p>
             <a:pPr algn="ctr">
@@ -8281,7 +8064,7 @@
           <a:noFill/>
         </p:spPr>
         <p:txBody>
-          <a:bodyPr wrap="square" lIns="0" tIns="0" rIns="0" bIns="0" anchor="t">
+          <a:bodyPr wrap="square" anchor="t" lIns="0" rIns="0" tIns="0" bIns="0">
             <a:spAutoFit/>
           </a:bodyPr>
           <a:lstStyle/>
@@ -8323,7 +8106,7 @@
           <a:noFill/>
         </p:spPr>
         <p:txBody>
-          <a:bodyPr wrap="square" lIns="0" tIns="0" rIns="0" bIns="0" anchor="t">
+          <a:bodyPr wrap="square" anchor="t" lIns="0" rIns="0" tIns="0" bIns="0">
             <a:spAutoFit/>
           </a:bodyPr>
           <a:lstStyle/>
@@ -8393,7 +8176,6 @@
           <a:lstStyle/>
           <a:p>
             <a:pPr algn="ctr"/>
-            <a:endParaRPr/>
           </a:p>
         </p:txBody>
       </p:sp>
@@ -8434,7 +8216,7 @@
           </a:fontRef>
         </p:style>
         <p:txBody>
-          <a:bodyPr lIns="0" tIns="0" rIns="0" bIns="0" rtlCol="0" anchor="ctr"/>
+          <a:bodyPr rtlCol="0" anchor="ctr" lIns="0" rIns="0" tIns="0" bIns="0"/>
           <a:lstStyle/>
           <a:p>
             <a:pPr algn="ctr">
@@ -8474,7 +8256,7 @@
           <a:noFill/>
         </p:spPr>
         <p:txBody>
-          <a:bodyPr wrap="square" lIns="0" tIns="0" rIns="0" bIns="0" anchor="t">
+          <a:bodyPr wrap="square" anchor="t" lIns="0" rIns="0" tIns="0" bIns="0">
             <a:spAutoFit/>
           </a:bodyPr>
           <a:lstStyle/>
@@ -8516,7 +8298,7 @@
           <a:noFill/>
         </p:spPr>
         <p:txBody>
-          <a:bodyPr wrap="square" lIns="0" tIns="0" rIns="0" bIns="0" anchor="t">
+          <a:bodyPr wrap="square" anchor="t" lIns="0" rIns="0" tIns="0" bIns="0">
             <a:spAutoFit/>
           </a:bodyPr>
           <a:lstStyle/>
@@ -8582,7 +8364,7 @@
           <a:noFill/>
         </p:spPr>
         <p:txBody>
-          <a:bodyPr wrap="square" lIns="0" tIns="0" rIns="0" bIns="0" anchor="ctr">
+          <a:bodyPr wrap="square" anchor="ctr" lIns="0" rIns="0" tIns="0" bIns="0">
             <a:spAutoFit/>
           </a:bodyPr>
           <a:lstStyle/>
@@ -8624,7 +8406,7 @@
           <a:noFill/>
         </p:spPr>
         <p:txBody>
-          <a:bodyPr wrap="square" lIns="0" tIns="0" rIns="0" bIns="0" anchor="ctr">
+          <a:bodyPr wrap="square" anchor="ctr" lIns="0" rIns="0" tIns="0" bIns="0">
             <a:spAutoFit/>
           </a:bodyPr>
           <a:lstStyle/>
@@ -8658,7 +8440,7 @@
 </file>
 
 <file path=ppt/slides/slide5.xml><?xml version="1.0" encoding="utf-8"?>
-<p:sld xmlns:a="http://schemas.openxmlformats.org/drawingml/2006/main" xmlns:r="http://schemas.openxmlformats.org/officeDocument/2006/relationships" xmlns:p="http://schemas.openxmlformats.org/presentationml/2006/main">
+<p:sld xmlns:a="http://schemas.openxmlformats.org/drawingml/2006/main" xmlns:p="http://schemas.openxmlformats.org/presentationml/2006/main" xmlns:r="http://schemas.openxmlformats.org/officeDocument/2006/relationships">
   <p:cSld>
     <p:bg>
       <p:bgPr>
@@ -8674,14 +8456,7 @@
         <p:cNvGrpSpPr/>
         <p:nvPr/>
       </p:nvGrpSpPr>
-      <p:grpSpPr>
-        <a:xfrm>
-          <a:off x="0" y="0"/>
-          <a:ext cx="0" cy="0"/>
-          <a:chOff x="0" y="0"/>
-          <a:chExt cx="0" cy="0"/>
-        </a:xfrm>
-      </p:grpSpPr>
+      <p:grpSpPr/>
       <p:sp>
         <p:nvSpPr>
           <p:cNvPr id="2" name="Rounded Rectangle 1"/>
@@ -8725,7 +8500,6 @@
           <a:lstStyle/>
           <a:p>
             <a:pPr algn="ctr"/>
-            <a:endParaRPr/>
           </a:p>
         </p:txBody>
       </p:sp>
@@ -8768,7 +8542,7 @@
           </a:fontRef>
         </p:style>
         <p:txBody>
-          <a:bodyPr wrap="none" lIns="0" tIns="0" rIns="0" bIns="0" rtlCol="0" anchor="ctr"/>
+          <a:bodyPr rtlCol="0" anchor="ctr" wrap="none" lIns="0" rIns="0" tIns="0" bIns="0"/>
           <a:lstStyle/>
           <a:p>
             <a:pPr algn="ctr">
@@ -8808,7 +8582,7 @@
           <a:noFill/>
         </p:spPr>
         <p:txBody>
-          <a:bodyPr wrap="square" lIns="0" tIns="0" rIns="0" bIns="0" anchor="t">
+          <a:bodyPr wrap="square" anchor="t" lIns="0" rIns="0" tIns="0" bIns="0">
             <a:spAutoFit/>
           </a:bodyPr>
           <a:lstStyle/>
@@ -8876,7 +8650,6 @@
           <a:lstStyle/>
           <a:p>
             <a:pPr algn="ctr"/>
-            <a:endParaRPr/>
           </a:p>
         </p:txBody>
       </p:sp>
@@ -8897,7 +8670,7 @@
           <a:noFill/>
         </p:spPr>
         <p:txBody>
-          <a:bodyPr wrap="square" lIns="0" tIns="0" rIns="0" bIns="0" anchor="t">
+          <a:bodyPr wrap="square" anchor="t" lIns="0" rIns="0" tIns="0" bIns="0">
             <a:spAutoFit/>
           </a:bodyPr>
           <a:lstStyle/>
@@ -8939,7 +8712,7 @@
           <a:noFill/>
         </p:spPr>
         <p:txBody>
-          <a:bodyPr wrap="square" lIns="0" tIns="0" rIns="0" bIns="0" anchor="t">
+          <a:bodyPr wrap="square" anchor="t" lIns="0" rIns="0" tIns="0" bIns="0">
             <a:spAutoFit/>
           </a:bodyPr>
           <a:lstStyle/>
@@ -8981,7 +8754,7 @@
           <a:noFill/>
         </p:spPr>
         <p:txBody>
-          <a:bodyPr wrap="square" lIns="0" tIns="0" rIns="0" bIns="0" anchor="t">
+          <a:bodyPr wrap="square" anchor="t" lIns="0" rIns="0" tIns="0" bIns="0">
             <a:spAutoFit/>
           </a:bodyPr>
           <a:lstStyle/>
@@ -9049,7 +8822,6 @@
           <a:lstStyle/>
           <a:p>
             <a:pPr algn="ctr"/>
-            <a:endParaRPr/>
           </a:p>
         </p:txBody>
       </p:sp>
@@ -9070,7 +8842,7 @@
           <a:noFill/>
         </p:spPr>
         <p:txBody>
-          <a:bodyPr wrap="square" lIns="0" tIns="0" rIns="0" bIns="0" anchor="t">
+          <a:bodyPr wrap="square" anchor="t" lIns="0" rIns="0" tIns="0" bIns="0">
             <a:spAutoFit/>
           </a:bodyPr>
           <a:lstStyle/>
@@ -9112,7 +8884,7 @@
           <a:noFill/>
         </p:spPr>
         <p:txBody>
-          <a:bodyPr wrap="square" lIns="0" tIns="0" rIns="0" bIns="0" anchor="t">
+          <a:bodyPr wrap="square" anchor="t" lIns="0" rIns="0" tIns="0" bIns="0">
             <a:spAutoFit/>
           </a:bodyPr>
           <a:lstStyle/>
@@ -9154,7 +8926,7 @@
           <a:noFill/>
         </p:spPr>
         <p:txBody>
-          <a:bodyPr wrap="square" lIns="0" tIns="0" rIns="0" bIns="0" anchor="t">
+          <a:bodyPr wrap="square" anchor="t" lIns="0" rIns="0" tIns="0" bIns="0">
             <a:spAutoFit/>
           </a:bodyPr>
           <a:lstStyle/>
@@ -9222,7 +8994,6 @@
           <a:lstStyle/>
           <a:p>
             <a:pPr algn="ctr"/>
-            <a:endParaRPr/>
           </a:p>
         </p:txBody>
       </p:sp>
@@ -9243,7 +9014,7 @@
           <a:noFill/>
         </p:spPr>
         <p:txBody>
-          <a:bodyPr wrap="square" lIns="0" tIns="0" rIns="0" bIns="0" anchor="t">
+          <a:bodyPr wrap="square" anchor="t" lIns="0" rIns="0" tIns="0" bIns="0">
             <a:spAutoFit/>
           </a:bodyPr>
           <a:lstStyle/>
@@ -9285,7 +9056,7 @@
           <a:noFill/>
         </p:spPr>
         <p:txBody>
-          <a:bodyPr wrap="square" lIns="0" tIns="0" rIns="0" bIns="0" anchor="t">
+          <a:bodyPr wrap="square" anchor="t" lIns="0" rIns="0" tIns="0" bIns="0">
             <a:spAutoFit/>
           </a:bodyPr>
           <a:lstStyle/>
@@ -9327,7 +9098,7 @@
           <a:noFill/>
         </p:spPr>
         <p:txBody>
-          <a:bodyPr wrap="square" lIns="0" tIns="0" rIns="0" bIns="0" anchor="t">
+          <a:bodyPr wrap="square" anchor="t" lIns="0" rIns="0" tIns="0" bIns="0">
             <a:spAutoFit/>
           </a:bodyPr>
           <a:lstStyle/>
@@ -9397,7 +9168,6 @@
           <a:lstStyle/>
           <a:p>
             <a:pPr algn="ctr"/>
-            <a:endParaRPr/>
           </a:p>
         </p:txBody>
       </p:sp>
@@ -9418,7 +9188,7 @@
           <a:noFill/>
         </p:spPr>
         <p:txBody>
-          <a:bodyPr wrap="square" lIns="0" tIns="0" rIns="0" bIns="0" anchor="t">
+          <a:bodyPr wrap="square" anchor="t" lIns="0" rIns="0" tIns="0" bIns="0">
             <a:spAutoFit/>
           </a:bodyPr>
           <a:lstStyle/>
@@ -9451,7 +9221,7 @@
         </p:nvSpPr>
         <p:spPr>
           <a:xfrm>
-            <a:off x="1143000" y="4635924"/>
+            <a:off x="1143000" y="4736592"/>
             <a:ext cx="4754880" cy="1005840"/>
           </a:xfrm>
           <a:prstGeom prst="rect">
@@ -9460,7 +9230,7 @@
           <a:noFill/>
         </p:spPr>
         <p:txBody>
-          <a:bodyPr wrap="square" lIns="0" tIns="0" rIns="0" bIns="0" anchor="t">
+          <a:bodyPr wrap="square" anchor="t" lIns="0" rIns="0" tIns="0" bIns="0">
             <a:spAutoFit/>
           </a:bodyPr>
           <a:lstStyle/>
@@ -9474,7 +9244,7 @@
               </a:spcAft>
             </a:pPr>
             <a:r>
-              <a:rPr sz="1100" b="0" i="0" dirty="0">
+              <a:rPr sz="1100" b="0" i="0">
                 <a:solidFill>
                   <a:srgbClr val="44587A"/>
                 </a:solidFill>
@@ -9493,7 +9263,7 @@
               </a:spcAft>
             </a:pPr>
             <a:r>
-              <a:rPr sz="1100" b="0" i="0" dirty="0">
+              <a:rPr sz="1100" b="0" i="0">
                 <a:solidFill>
                   <a:srgbClr val="44587A"/>
                 </a:solidFill>
@@ -9512,7 +9282,7 @@
               </a:spcAft>
             </a:pPr>
             <a:r>
-              <a:rPr sz="1100" b="0" i="0" dirty="0">
+              <a:rPr sz="1100" b="0" i="0">
                 <a:solidFill>
                   <a:srgbClr val="44587A"/>
                 </a:solidFill>
@@ -9531,7 +9301,7 @@
               </a:spcAft>
             </a:pPr>
             <a:r>
-              <a:rPr sz="1100" b="0" i="0" dirty="0">
+              <a:rPr sz="1100" b="0" i="0">
                 <a:solidFill>
                   <a:srgbClr val="44587A"/>
                 </a:solidFill>
@@ -9587,7 +9357,6 @@
           <a:lstStyle/>
           <a:p>
             <a:pPr algn="ctr"/>
-            <a:endParaRPr/>
           </a:p>
         </p:txBody>
       </p:sp>
@@ -9608,7 +9377,7 @@
           <a:noFill/>
         </p:spPr>
         <p:txBody>
-          <a:bodyPr wrap="square" lIns="0" tIns="0" rIns="0" bIns="0" anchor="t">
+          <a:bodyPr wrap="square" anchor="t" lIns="0" rIns="0" tIns="0" bIns="0">
             <a:spAutoFit/>
           </a:bodyPr>
           <a:lstStyle/>
@@ -9641,7 +9410,7 @@
         </p:nvSpPr>
         <p:spPr>
           <a:xfrm>
-            <a:off x="6537960" y="4610757"/>
+            <a:off x="6537960" y="4736592"/>
             <a:ext cx="4663440" cy="1005840"/>
           </a:xfrm>
           <a:prstGeom prst="rect">
@@ -9650,7 +9419,7 @@
           <a:noFill/>
         </p:spPr>
         <p:txBody>
-          <a:bodyPr wrap="square" lIns="0" tIns="0" rIns="0" bIns="0" anchor="t">
+          <a:bodyPr wrap="square" anchor="t" lIns="0" rIns="0" tIns="0" bIns="0">
             <a:spAutoFit/>
           </a:bodyPr>
           <a:lstStyle/>
@@ -9664,7 +9433,7 @@
               </a:spcAft>
             </a:pPr>
             <a:r>
-              <a:rPr sz="1100" b="0" i="0" dirty="0">
+              <a:rPr sz="1100" b="0" i="0">
                 <a:solidFill>
                   <a:srgbClr val="44587A"/>
                 </a:solidFill>
@@ -9683,7 +9452,7 @@
               </a:spcAft>
             </a:pPr>
             <a:r>
-              <a:rPr sz="1100" b="0" i="0" dirty="0">
+              <a:rPr sz="1100" b="0" i="0">
                 <a:solidFill>
                   <a:srgbClr val="44587A"/>
                 </a:solidFill>
@@ -9702,7 +9471,7 @@
               </a:spcAft>
             </a:pPr>
             <a:r>
-              <a:rPr sz="1100" b="0" i="0" dirty="0">
+              <a:rPr sz="1100" b="0" i="0">
                 <a:solidFill>
                   <a:srgbClr val="44587A"/>
                 </a:solidFill>
@@ -9721,7 +9490,7 @@
               </a:spcAft>
             </a:pPr>
             <a:r>
-              <a:rPr sz="1100" b="0" i="0" dirty="0">
+              <a:rPr sz="1100" b="0" i="0">
                 <a:solidFill>
                   <a:srgbClr val="44587A"/>
                 </a:solidFill>
@@ -9749,7 +9518,7 @@
           <a:noFill/>
         </p:spPr>
         <p:txBody>
-          <a:bodyPr wrap="square" lIns="0" tIns="0" rIns="0" bIns="0" anchor="t">
+          <a:bodyPr wrap="square" anchor="t" lIns="0" rIns="0" tIns="0" bIns="0">
             <a:spAutoFit/>
           </a:bodyPr>
           <a:lstStyle/>
@@ -9815,7 +9584,7 @@
           <a:noFill/>
         </p:spPr>
         <p:txBody>
-          <a:bodyPr wrap="square" lIns="0" tIns="0" rIns="0" bIns="0" anchor="ctr">
+          <a:bodyPr wrap="square" anchor="ctr" lIns="0" rIns="0" tIns="0" bIns="0">
             <a:spAutoFit/>
           </a:bodyPr>
           <a:lstStyle/>
@@ -9857,7 +9626,7 @@
           <a:noFill/>
         </p:spPr>
         <p:txBody>
-          <a:bodyPr wrap="square" lIns="0" tIns="0" rIns="0" bIns="0" anchor="ctr">
+          <a:bodyPr wrap="square" anchor="ctr" lIns="0" rIns="0" tIns="0" bIns="0">
             <a:spAutoFit/>
           </a:bodyPr>
           <a:lstStyle/>
@@ -9891,7 +9660,7 @@
 </file>
 
 <file path=ppt/slides/slide6.xml><?xml version="1.0" encoding="utf-8"?>
-<p:sld xmlns:a="http://schemas.openxmlformats.org/drawingml/2006/main" xmlns:r="http://schemas.openxmlformats.org/officeDocument/2006/relationships" xmlns:p="http://schemas.openxmlformats.org/presentationml/2006/main">
+<p:sld xmlns:a="http://schemas.openxmlformats.org/drawingml/2006/main" xmlns:p="http://schemas.openxmlformats.org/presentationml/2006/main" xmlns:r="http://schemas.openxmlformats.org/officeDocument/2006/relationships">
   <p:cSld>
     <p:bg>
       <p:bgPr>
@@ -9907,14 +9676,7 @@
         <p:cNvGrpSpPr/>
         <p:nvPr/>
       </p:nvGrpSpPr>
-      <p:grpSpPr>
-        <a:xfrm>
-          <a:off x="0" y="0"/>
-          <a:ext cx="0" cy="0"/>
-          <a:chOff x="0" y="0"/>
-          <a:chExt cx="0" cy="0"/>
-        </a:xfrm>
-      </p:grpSpPr>
+      <p:grpSpPr/>
       <p:sp>
         <p:nvSpPr>
           <p:cNvPr id="2" name="Rounded Rectangle 1"/>
@@ -9958,7 +9720,6 @@
           <a:lstStyle/>
           <a:p>
             <a:pPr algn="ctr"/>
-            <a:endParaRPr/>
           </a:p>
         </p:txBody>
       </p:sp>
@@ -10005,7 +9766,6 @@
           <a:lstStyle/>
           <a:p>
             <a:pPr algn="ctr"/>
-            <a:endParaRPr/>
           </a:p>
         </p:txBody>
       </p:sp>
@@ -10050,7 +9810,6 @@
           <a:lstStyle/>
           <a:p>
             <a:pPr algn="ctr"/>
-            <a:endParaRPr/>
           </a:p>
         </p:txBody>
       </p:sp>
@@ -10093,7 +9852,7 @@
           </a:fontRef>
         </p:style>
         <p:txBody>
-          <a:bodyPr wrap="none" lIns="0" tIns="0" rIns="0" bIns="0" rtlCol="0" anchor="ctr"/>
+          <a:bodyPr rtlCol="0" anchor="ctr" wrap="none" lIns="0" rIns="0" tIns="0" bIns="0"/>
           <a:lstStyle/>
           <a:p>
             <a:pPr algn="ctr">
@@ -10133,7 +9892,7 @@
           <a:noFill/>
         </p:spPr>
         <p:txBody>
-          <a:bodyPr wrap="square" lIns="0" tIns="0" rIns="0" bIns="0" anchor="t">
+          <a:bodyPr wrap="square" anchor="t" lIns="0" rIns="0" tIns="0" bIns="0">
             <a:spAutoFit/>
           </a:bodyPr>
           <a:lstStyle/>
@@ -10195,7 +9954,7 @@
           </a:fontRef>
         </p:style>
         <p:txBody>
-          <a:bodyPr lIns="0" tIns="0" rIns="0" bIns="0" rtlCol="0" anchor="ctr"/>
+          <a:bodyPr rtlCol="0" anchor="ctr" lIns="0" rIns="0" tIns="0" bIns="0"/>
           <a:lstStyle/>
           <a:p>
             <a:pPr algn="ctr">
@@ -10235,7 +9994,7 @@
           <a:noFill/>
         </p:spPr>
         <p:txBody>
-          <a:bodyPr wrap="square" lIns="0" tIns="0" rIns="0" bIns="0" anchor="t">
+          <a:bodyPr wrap="square" anchor="t" lIns="0" rIns="0" tIns="0" bIns="0">
             <a:spAutoFit/>
           </a:bodyPr>
           <a:lstStyle/>
@@ -10277,7 +10036,7 @@
           <a:noFill/>
         </p:spPr>
         <p:txBody>
-          <a:bodyPr wrap="square" lIns="0" tIns="0" rIns="0" bIns="0" anchor="t">
+          <a:bodyPr wrap="square" anchor="t" lIns="0" rIns="0" tIns="0" bIns="0">
             <a:spAutoFit/>
           </a:bodyPr>
           <a:lstStyle/>
@@ -10339,7 +10098,7 @@
           </a:fontRef>
         </p:style>
         <p:txBody>
-          <a:bodyPr lIns="0" tIns="0" rIns="0" bIns="0" rtlCol="0" anchor="ctr"/>
+          <a:bodyPr rtlCol="0" anchor="ctr" lIns="0" rIns="0" tIns="0" bIns="0"/>
           <a:lstStyle/>
           <a:p>
             <a:pPr algn="ctr">
@@ -10379,7 +10138,7 @@
           <a:noFill/>
         </p:spPr>
         <p:txBody>
-          <a:bodyPr wrap="square" lIns="0" tIns="0" rIns="0" bIns="0" anchor="t">
+          <a:bodyPr wrap="square" anchor="t" lIns="0" rIns="0" tIns="0" bIns="0">
             <a:spAutoFit/>
           </a:bodyPr>
           <a:lstStyle/>
@@ -10421,7 +10180,7 @@
           <a:noFill/>
         </p:spPr>
         <p:txBody>
-          <a:bodyPr wrap="square" lIns="0" tIns="0" rIns="0" bIns="0" anchor="t">
+          <a:bodyPr wrap="square" anchor="t" lIns="0" rIns="0" tIns="0" bIns="0">
             <a:spAutoFit/>
           </a:bodyPr>
           <a:lstStyle/>
@@ -10489,48 +10248,29 @@
           <a:lstStyle/>
           <a:p>
             <a:pPr algn="ctr"/>
-            <a:endParaRPr/>
-          </a:p>
-        </p:txBody>
-      </p:sp>
-      <p:sp>
-        <p:nvSpPr>
-          <p:cNvPr id="14" name="Oval 13"/>
-          <p:cNvSpPr/>
-          <p:nvPr/>
-        </p:nvSpPr>
-        <p:spPr>
-          <a:xfrm>
-            <a:off x="1097280" y="4297680"/>
-            <a:ext cx="457200" cy="457200"/>
-          </a:xfrm>
-          <a:prstGeom prst="ellipse">
-            <a:avLst/>
-          </a:prstGeom>
-          <a:solidFill>
-            <a:srgbClr val="F26522"/>
-          </a:solidFill>
-          <a:ln>
-            <a:noFill/>
-          </a:ln>
-          <a:effectLst/>
-        </p:spPr>
-        <p:style>
-          <a:lnRef idx="1">
-            <a:schemeClr val="accent1"/>
-          </a:lnRef>
-          <a:fillRef idx="3">
-            <a:schemeClr val="accent1"/>
-          </a:fillRef>
-          <a:effectRef idx="2">
-            <a:schemeClr val="accent1"/>
-          </a:effectRef>
-          <a:fontRef idx="minor">
-            <a:schemeClr val="lt1"/>
-          </a:fontRef>
-        </p:style>
-        <p:txBody>
-          <a:bodyPr lIns="0" tIns="0" rIns="0" bIns="0" rtlCol="0" anchor="ctr"/>
+          </a:p>
+        </p:txBody>
+      </p:sp>
+      <p:sp>
+        <p:nvSpPr>
+          <p:cNvPr id="14" name="TextBox 13"/>
+          <p:cNvSpPr txBox="1"/>
+          <p:nvPr/>
+        </p:nvSpPr>
+        <p:spPr>
+          <a:xfrm>
+            <a:off x="1097280" y="4206240"/>
+            <a:ext cx="548640" cy="502920"/>
+          </a:xfrm>
+          <a:prstGeom prst="rect">
+            <a:avLst/>
+          </a:prstGeom>
+          <a:noFill/>
+        </p:spPr>
+        <p:txBody>
+          <a:bodyPr wrap="square" anchor="ctr" lIns="0" rIns="0" tIns="0" bIns="0">
+            <a:spAutoFit/>
+          </a:bodyPr>
           <a:lstStyle/>
           <a:p>
             <a:pPr algn="ctr">
@@ -10542,13 +10282,13 @@
               </a:spcAft>
             </a:pPr>
             <a:r>
-              <a:rPr sz="1300" b="1" i="0">
-                <a:solidFill>
-                  <a:srgbClr val="FFFFFF"/>
-                </a:solidFill>
-                <a:latin typeface="Calibri"/>
-              </a:rPr>
-              <a:t>▶</a:t>
+              <a:rPr sz="2600" b="1" i="0">
+                <a:solidFill>
+                  <a:srgbClr val="F26522"/>
+                </a:solidFill>
+                <a:latin typeface="Segoe UI Symbol"/>
+              </a:rPr>
+              <a:t>✈</a:t>
             </a:r>
           </a:p>
         </p:txBody>
@@ -10561,8 +10301,8 @@
         </p:nvSpPr>
         <p:spPr>
           <a:xfrm>
-            <a:off x="1691640" y="4315968"/>
-            <a:ext cx="5943600" cy="365760"/>
+            <a:off x="1783080" y="4315968"/>
+            <a:ext cx="5852160" cy="365760"/>
           </a:xfrm>
           <a:prstGeom prst="rect">
             <a:avLst/>
@@ -10570,7 +10310,7 @@
           <a:noFill/>
         </p:spPr>
         <p:txBody>
-          <a:bodyPr wrap="square" lIns="0" tIns="0" rIns="0" bIns="0" anchor="t">
+          <a:bodyPr wrap="square" anchor="t" lIns="0" rIns="0" tIns="0" bIns="0">
             <a:spAutoFit/>
           </a:bodyPr>
           <a:lstStyle/>
@@ -10612,7 +10352,7 @@
           <a:noFill/>
         </p:spPr>
         <p:txBody>
-          <a:bodyPr wrap="square" lIns="0" tIns="0" rIns="0" bIns="0" anchor="t">
+          <a:bodyPr wrap="square" anchor="t" lIns="0" rIns="0" tIns="0" bIns="0">
             <a:spAutoFit/>
           </a:bodyPr>
           <a:lstStyle/>
@@ -10692,7 +10432,7 @@
           <a:noFill/>
         </p:spPr>
         <p:txBody>
-          <a:bodyPr wrap="square" lIns="0" tIns="0" rIns="0" bIns="0" anchor="t">
+          <a:bodyPr wrap="square" anchor="t" lIns="0" rIns="0" tIns="0" bIns="0">
             <a:spAutoFit/>
           </a:bodyPr>
           <a:lstStyle/>
@@ -10758,7 +10498,7 @@
           <a:noFill/>
         </p:spPr>
         <p:txBody>
-          <a:bodyPr wrap="square" lIns="0" tIns="0" rIns="0" bIns="0" anchor="ctr">
+          <a:bodyPr wrap="square" anchor="ctr" lIns="0" rIns="0" tIns="0" bIns="0">
             <a:spAutoFit/>
           </a:bodyPr>
           <a:lstStyle/>
@@ -10800,7 +10540,7 @@
           <a:noFill/>
         </p:spPr>
         <p:txBody>
-          <a:bodyPr wrap="square" lIns="0" tIns="0" rIns="0" bIns="0" anchor="ctr">
+          <a:bodyPr wrap="square" anchor="ctr" lIns="0" rIns="0" tIns="0" bIns="0">
             <a:spAutoFit/>
           </a:bodyPr>
           <a:lstStyle/>

</xml_diff>